<commit_message>
Add extended-day enrollment, activity choices, and health/dietary breakdowns
- Restrict form-gated fields (ASE, RTP, PEI, PC/Internet, oferta de escola,
  autorização de saída) to students who actually stay for extended-day
  activities - confirmed empirically that non-staying students have these
  ~90% blank, so including them understated every rate (ASE 39%->58%).
- Add categorized (never verbatim) health-condition and dietary-restriction
  breakdowns, with the same small-group suppression rule used for rare
  nationalities.
- Add activity-choice counts by rank and by grade.
- Fix a stray casing typo in the source data ("musica" vs "Música").
- Wire all of the above into the notebook, dashboard, and slide deck.
</commit_message>
<xml_diff>
--- a/slides/apresentacao.pptx
+++ b/slides/apresentacao.pptx
@@ -15,6 +15,9 @@
     <p:sldId id="263" r:id="rId14"/>
     <p:sldId id="264" r:id="rId15"/>
     <p:sldId id="265" r:id="rId16"/>
+    <p:sldId id="266" r:id="rId17"/>
+    <p:sldId id="267" r:id="rId18"/>
+    <p:sldId id="268" r:id="rId19"/>
   </p:sldIdLst>
   <p:sldSz cx="12191695" cy="6858000" type="screen4x3"/>
   <p:notesSz cx="6858000" cy="9144000"/>
@@ -3291,6 +3294,901 @@
             <a:avLst/>
           </a:prstGeom>
           <a:solidFill>
+            <a:srgbClr val="FFFFFF"/>
+          </a:solidFill>
+          <a:ln>
+            <a:noFill/>
+          </a:ln>
+          <a:effectLst/>
+        </p:spPr>
+        <p:style>
+          <a:lnRef idx="1">
+            <a:schemeClr val="accent1"/>
+          </a:lnRef>
+          <a:fillRef idx="3">
+            <a:schemeClr val="accent1"/>
+          </a:fillRef>
+          <a:effectRef idx="2">
+            <a:schemeClr val="accent1"/>
+          </a:effectRef>
+          <a:fontRef idx="minor">
+            <a:schemeClr val="lt1"/>
+          </a:fontRef>
+        </p:style>
+        <p:txBody>
+          <a:bodyPr rtlCol="0" anchor="ctr"/>
+          <a:lstStyle/>
+          <a:p>
+            <a:pPr algn="ctr"/>
+          </a:p>
+        </p:txBody>
+      </p:sp>
+      <p:sp>
+        <p:nvSpPr>
+          <p:cNvPr id="3" name="TextBox 2"/>
+          <p:cNvSpPr txBox="1"/>
+          <p:nvPr/>
+        </p:nvSpPr>
+        <p:spPr>
+          <a:xfrm>
+            <a:off x="640080" y="502920"/>
+            <a:ext cx="10881360" cy="822960"/>
+          </a:xfrm>
+          <a:prstGeom prst="rect">
+            <a:avLst/>
+          </a:prstGeom>
+          <a:noFill/>
+        </p:spPr>
+        <p:txBody>
+          <a:bodyPr wrap="square" anchor="t" lIns="0" rIns="0" tIns="0" bIns="0">
+            <a:spAutoFit/>
+          </a:bodyPr>
+          <a:lstStyle/>
+          <a:p>
+            <a:pPr algn="l">
+              <a:lnSpc>
+                <a:spcPct val="100000"/>
+              </a:lnSpc>
+            </a:pPr>
+            <a:r>
+              <a:rPr sz="2600" b="1" i="0">
+                <a:solidFill>
+                  <a:srgbClr val="1C4F52"/>
+                </a:solidFill>
+                <a:latin typeface="Calibri"/>
+              </a:rPr>
+              <a:t>Condições de saúde e restrições alimentares</a:t>
+            </a:r>
+          </a:p>
+        </p:txBody>
+      </p:sp>
+      <p:pic>
+        <p:nvPicPr>
+          <p:cNvPr id="4" name="Picture 3" descr="chart_saude.png"/>
+          <p:cNvPicPr>
+            <a:picLocks noChangeAspect="1"/>
+          </p:cNvPicPr>
+          <p:nvPr/>
+        </p:nvPicPr>
+        <p:blipFill>
+          <a:blip r:embed="rId2"/>
+          <a:stretch>
+            <a:fillRect/>
+          </a:stretch>
+        </p:blipFill>
+        <p:spPr>
+          <a:xfrm>
+            <a:off x="1134461" y="1371600"/>
+            <a:ext cx="4406198" cy="2468880"/>
+          </a:xfrm>
+          <a:prstGeom prst="rect">
+            <a:avLst/>
+          </a:prstGeom>
+        </p:spPr>
+      </p:pic>
+      <p:pic>
+        <p:nvPicPr>
+          <p:cNvPr id="5" name="Picture 4" descr="chart_dieta.png"/>
+          <p:cNvPicPr>
+            <a:picLocks noChangeAspect="1"/>
+          </p:cNvPicPr>
+          <p:nvPr/>
+        </p:nvPicPr>
+        <p:blipFill>
+          <a:blip r:embed="rId3"/>
+          <a:stretch>
+            <a:fillRect/>
+          </a:stretch>
+        </p:blipFill>
+        <p:spPr>
+          <a:xfrm>
+            <a:off x="965288" y="3931920"/>
+            <a:ext cx="4744543" cy="2377440"/>
+          </a:xfrm>
+          <a:prstGeom prst="rect">
+            <a:avLst/>
+          </a:prstGeom>
+        </p:spPr>
+      </p:pic>
+      <p:sp>
+        <p:nvSpPr>
+          <p:cNvPr id="6" name="TextBox 5"/>
+          <p:cNvSpPr txBox="1"/>
+          <p:nvPr/>
+        </p:nvSpPr>
+        <p:spPr>
+          <a:xfrm>
+            <a:off x="6492240" y="1554480"/>
+            <a:ext cx="5029200" cy="914400"/>
+          </a:xfrm>
+          <a:prstGeom prst="rect">
+            <a:avLst/>
+          </a:prstGeom>
+          <a:noFill/>
+        </p:spPr>
+        <p:txBody>
+          <a:bodyPr wrap="square" anchor="t" lIns="0" rIns="0" tIns="0" bIns="0">
+            <a:spAutoFit/>
+          </a:bodyPr>
+          <a:lstStyle/>
+          <a:p>
+            <a:pPr algn="l">
+              <a:lnSpc>
+                <a:spcPct val="100000"/>
+              </a:lnSpc>
+            </a:pPr>
+            <a:r>
+              <a:rPr sz="1800" b="1" i="0">
+                <a:solidFill>
+                  <a:srgbClr val="C1592B"/>
+                </a:solidFill>
+                <a:latin typeface="Calibri"/>
+              </a:rPr>
+              <a:t>81% sem condição de saúde referida</a:t>
+            </a:r>
+          </a:p>
+        </p:txBody>
+      </p:sp>
+      <p:sp>
+        <p:nvSpPr>
+          <p:cNvPr id="7" name="TextBox 6"/>
+          <p:cNvSpPr txBox="1"/>
+          <p:nvPr/>
+        </p:nvSpPr>
+        <p:spPr>
+          <a:xfrm>
+            <a:off x="6492240" y="2286000"/>
+            <a:ext cx="5029200" cy="1463040"/>
+          </a:xfrm>
+          <a:prstGeom prst="rect">
+            <a:avLst/>
+          </a:prstGeom>
+          <a:noFill/>
+        </p:spPr>
+        <p:txBody>
+          <a:bodyPr wrap="square" anchor="t" lIns="0" rIns="0" tIns="0" bIns="0">
+            <a:spAutoFit/>
+          </a:bodyPr>
+          <a:lstStyle/>
+          <a:p>
+            <a:pPr algn="l">
+              <a:lnSpc>
+                <a:spcPct val="120000"/>
+              </a:lnSpc>
+            </a:pPr>
+            <a:r>
+              <a:rPr sz="1400" b="0" i="0">
+                <a:solidFill>
+                  <a:srgbClr val="1A1A1A"/>
+                </a:solidFill>
+                <a:latin typeface="Calibri"/>
+              </a:rPr>
+              <a:t>Entre os restantes, predominam problemas respiratórios (asma/bronquite) e défice de atenção/hiperatividade.</a:t>
+            </a:r>
+          </a:p>
+        </p:txBody>
+      </p:sp>
+      <p:sp>
+        <p:nvSpPr>
+          <p:cNvPr id="8" name="TextBox 7"/>
+          <p:cNvSpPr txBox="1"/>
+          <p:nvPr/>
+        </p:nvSpPr>
+        <p:spPr>
+          <a:xfrm>
+            <a:off x="6492240" y="3931920"/>
+            <a:ext cx="5029200" cy="914400"/>
+          </a:xfrm>
+          <a:prstGeom prst="rect">
+            <a:avLst/>
+          </a:prstGeom>
+          <a:noFill/>
+        </p:spPr>
+        <p:txBody>
+          <a:bodyPr wrap="square" anchor="t" lIns="0" rIns="0" tIns="0" bIns="0">
+            <a:spAutoFit/>
+          </a:bodyPr>
+          <a:lstStyle/>
+          <a:p>
+            <a:pPr algn="l">
+              <a:lnSpc>
+                <a:spcPct val="100000"/>
+              </a:lnSpc>
+            </a:pPr>
+            <a:r>
+              <a:rPr sz="1800" b="1" i="0">
+                <a:solidFill>
+                  <a:srgbClr val="C1592B"/>
+                </a:solidFill>
+                <a:latin typeface="Calibri"/>
+              </a:rPr>
+              <a:t>91% sem restrição alimentar referida</a:t>
+            </a:r>
+          </a:p>
+        </p:txBody>
+      </p:sp>
+      <p:sp>
+        <p:nvSpPr>
+          <p:cNvPr id="9" name="TextBox 8"/>
+          <p:cNvSpPr txBox="1"/>
+          <p:nvPr/>
+        </p:nvSpPr>
+        <p:spPr>
+          <a:xfrm>
+            <a:off x="6492240" y="4663440"/>
+            <a:ext cx="5029200" cy="1463040"/>
+          </a:xfrm>
+          <a:prstGeom prst="rect">
+            <a:avLst/>
+          </a:prstGeom>
+          <a:noFill/>
+        </p:spPr>
+        <p:txBody>
+          <a:bodyPr wrap="square" anchor="t" lIns="0" rIns="0" tIns="0" bIns="0">
+            <a:spAutoFit/>
+          </a:bodyPr>
+          <a:lstStyle/>
+          <a:p>
+            <a:pPr algn="l">
+              <a:lnSpc>
+                <a:spcPct val="120000"/>
+              </a:lnSpc>
+            </a:pPr>
+            <a:r>
+              <a:rPr sz="1400" b="0" i="0">
+                <a:solidFill>
+                  <a:srgbClr val="1A1A1A"/>
+                </a:solidFill>
+                <a:latin typeface="Calibri"/>
+              </a:rPr>
+              <a:t>Entre os restantes, destaca-se a não-ingestão de porco/vaca (motivo cultural ou religioso) — reflexo direto da diversidade da escola.</a:t>
+            </a:r>
+          </a:p>
+        </p:txBody>
+      </p:sp>
+      <p:sp>
+        <p:nvSpPr>
+          <p:cNvPr id="10" name="TextBox 9"/>
+          <p:cNvSpPr txBox="1"/>
+          <p:nvPr/>
+        </p:nvSpPr>
+        <p:spPr>
+          <a:xfrm>
+            <a:off x="548640" y="6473952"/>
+            <a:ext cx="8229600" cy="320040"/>
+          </a:xfrm>
+          <a:prstGeom prst="rect">
+            <a:avLst/>
+          </a:prstGeom>
+          <a:noFill/>
+        </p:spPr>
+        <p:txBody>
+          <a:bodyPr wrap="square" anchor="t" lIns="0" rIns="0" tIns="0" bIns="0">
+            <a:spAutoFit/>
+          </a:bodyPr>
+          <a:lstStyle/>
+          <a:p>
+            <a:pPr algn="l">
+              <a:lnSpc>
+                <a:spcPct val="100000"/>
+              </a:lnSpc>
+            </a:pPr>
+            <a:r>
+              <a:rPr sz="1000" b="0" i="1">
+                <a:solidFill>
+                  <a:srgbClr val="52514E"/>
+                </a:solidFill>
+                <a:latin typeface="Calibri"/>
+              </a:rPr>
+              <a:t>Categorias amplas, nunca o diagnóstico literal — ver metodologia de anonimização</a:t>
+            </a:r>
+          </a:p>
+        </p:txBody>
+      </p:sp>
+      <p:sp>
+        <p:nvSpPr>
+          <p:cNvPr id="11" name="TextBox 10"/>
+          <p:cNvSpPr txBox="1"/>
+          <p:nvPr/>
+        </p:nvSpPr>
+        <p:spPr>
+          <a:xfrm>
+            <a:off x="10241280" y="6473952"/>
+            <a:ext cx="1371600" cy="320040"/>
+          </a:xfrm>
+          <a:prstGeom prst="rect">
+            <a:avLst/>
+          </a:prstGeom>
+          <a:noFill/>
+        </p:spPr>
+        <p:txBody>
+          <a:bodyPr wrap="square" anchor="t" lIns="0" rIns="0" tIns="0" bIns="0">
+            <a:spAutoFit/>
+          </a:bodyPr>
+          <a:lstStyle/>
+          <a:p>
+            <a:pPr algn="r">
+              <a:lnSpc>
+                <a:spcPct val="100000"/>
+              </a:lnSpc>
+            </a:pPr>
+            <a:r>
+              <a:rPr sz="1000" b="0" i="1">
+                <a:solidFill>
+                  <a:srgbClr val="52514E"/>
+                </a:solidFill>
+                <a:latin typeface="Calibri"/>
+              </a:rPr>
+              <a:t>Escola Francisco de Arruda</a:t>
+            </a:r>
+          </a:p>
+        </p:txBody>
+      </p:sp>
+    </p:spTree>
+  </p:cSld>
+  <p:clrMapOvr>
+    <a:masterClrMapping/>
+  </p:clrMapOvr>
+</p:sld>
+</file>
+
+<file path=ppt/slides/slide11.xml><?xml version="1.0" encoding="utf-8"?>
+<p:sld xmlns:a="http://schemas.openxmlformats.org/drawingml/2006/main" xmlns:p="http://schemas.openxmlformats.org/presentationml/2006/main" xmlns:r="http://schemas.openxmlformats.org/officeDocument/2006/relationships">
+  <p:cSld>
+    <p:spTree>
+      <p:nvGrpSpPr>
+        <p:cNvPr id="1" name=""/>
+        <p:cNvGrpSpPr/>
+        <p:nvPr/>
+      </p:nvGrpSpPr>
+      <p:grpSpPr/>
+      <p:sp>
+        <p:nvSpPr>
+          <p:cNvPr id="2" name="Rectangle 1"/>
+          <p:cNvSpPr/>
+          <p:nvPr/>
+        </p:nvSpPr>
+        <p:spPr>
+          <a:xfrm>
+            <a:off x="0" y="0"/>
+            <a:ext cx="12191695" cy="6858000"/>
+          </a:xfrm>
+          <a:prstGeom prst="rect">
+            <a:avLst/>
+          </a:prstGeom>
+          <a:solidFill>
+            <a:srgbClr val="FFFFFF"/>
+          </a:solidFill>
+          <a:ln>
+            <a:noFill/>
+          </a:ln>
+          <a:effectLst/>
+        </p:spPr>
+        <p:style>
+          <a:lnRef idx="1">
+            <a:schemeClr val="accent1"/>
+          </a:lnRef>
+          <a:fillRef idx="3">
+            <a:schemeClr val="accent1"/>
+          </a:fillRef>
+          <a:effectRef idx="2">
+            <a:schemeClr val="accent1"/>
+          </a:effectRef>
+          <a:fontRef idx="minor">
+            <a:schemeClr val="lt1"/>
+          </a:fontRef>
+        </p:style>
+        <p:txBody>
+          <a:bodyPr rtlCol="0" anchor="ctr"/>
+          <a:lstStyle/>
+          <a:p>
+            <a:pPr algn="ctr"/>
+          </a:p>
+        </p:txBody>
+      </p:sp>
+      <p:sp>
+        <p:nvSpPr>
+          <p:cNvPr id="3" name="TextBox 2"/>
+          <p:cNvSpPr txBox="1"/>
+          <p:nvPr/>
+        </p:nvSpPr>
+        <p:spPr>
+          <a:xfrm>
+            <a:off x="640080" y="502920"/>
+            <a:ext cx="10881360" cy="822960"/>
+          </a:xfrm>
+          <a:prstGeom prst="rect">
+            <a:avLst/>
+          </a:prstGeom>
+          <a:noFill/>
+        </p:spPr>
+        <p:txBody>
+          <a:bodyPr wrap="square" anchor="t" lIns="0" rIns="0" tIns="0" bIns="0">
+            <a:spAutoFit/>
+          </a:bodyPr>
+          <a:lstStyle/>
+          <a:p>
+            <a:pPr algn="l">
+              <a:lnSpc>
+                <a:spcPct val="100000"/>
+              </a:lnSpc>
+            </a:pPr>
+            <a:r>
+              <a:rPr sz="2600" b="1" i="0">
+                <a:solidFill>
+                  <a:srgbClr val="1C4F52"/>
+                </a:solidFill>
+                <a:latin typeface="Calibri"/>
+              </a:rPr>
+              <a:t>Qualidade dos dados — uma oportunidade de melhoria</a:t>
+            </a:r>
+          </a:p>
+        </p:txBody>
+      </p:sp>
+      <p:pic>
+        <p:nvPicPr>
+          <p:cNvPr id="4" name="Picture 3" descr="chart_missing_data.png"/>
+          <p:cNvPicPr>
+            <a:picLocks noChangeAspect="1"/>
+          </p:cNvPicPr>
+          <p:nvPr/>
+        </p:nvPicPr>
+        <p:blipFill>
+          <a:blip r:embed="rId2"/>
+          <a:stretch>
+            <a:fillRect/>
+          </a:stretch>
+        </p:blipFill>
+        <p:spPr>
+          <a:xfrm>
+            <a:off x="640080" y="1556958"/>
+            <a:ext cx="6949440" cy="4567043"/>
+          </a:xfrm>
+          <a:prstGeom prst="rect">
+            <a:avLst/>
+          </a:prstGeom>
+        </p:spPr>
+      </p:pic>
+      <p:sp>
+        <p:nvSpPr>
+          <p:cNvPr id="5" name="TextBox 4"/>
+          <p:cNvSpPr txBox="1"/>
+          <p:nvPr/>
+        </p:nvSpPr>
+        <p:spPr>
+          <a:xfrm>
+            <a:off x="7863840" y="1920240"/>
+            <a:ext cx="3749039" cy="4297680"/>
+          </a:xfrm>
+          <a:prstGeom prst="rect">
+            <a:avLst/>
+          </a:prstGeom>
+          <a:noFill/>
+        </p:spPr>
+        <p:txBody>
+          <a:bodyPr wrap="square" anchor="t" lIns="0" rIns="0" tIns="0" bIns="0">
+            <a:spAutoFit/>
+          </a:bodyPr>
+          <a:lstStyle/>
+          <a:p>
+            <a:pPr algn="l">
+              <a:lnSpc>
+                <a:spcPct val="125000"/>
+              </a:lnSpc>
+            </a:pPr>
+            <a:r>
+              <a:rPr sz="1500" b="0" i="0">
+                <a:solidFill>
+                  <a:srgbClr val="1A1A1A"/>
+                </a:solidFill>
+                <a:latin typeface="Calibri"/>
+              </a:rPr>
+              <a:t>Vários campos têm 30%+ de valores em falta — incluindo nacionalidade e data de nascimento em alguns casos.</a:t>
+            </a:r>
+          </a:p>
+          <a:p>
+            <a:pPr algn="l">
+              <a:lnSpc>
+                <a:spcPct val="125000"/>
+              </a:lnSpc>
+            </a:pPr>
+            <a:r>
+              <a:rPr sz="1500" b="0" i="0">
+                <a:solidFill>
+                  <a:srgbClr val="1A1A1A"/>
+                </a:solidFill>
+                <a:latin typeface="Calibri"/>
+              </a:rPr>
+              <a:t/>
+            </a:r>
+          </a:p>
+          <a:p>
+            <a:pPr algn="l">
+              <a:lnSpc>
+                <a:spcPct val="125000"/>
+              </a:lnSpc>
+            </a:pPr>
+            <a:r>
+              <a:rPr sz="1500" b="0" i="0">
+                <a:solidFill>
+                  <a:srgbClr val="1A1A1A"/>
+                </a:solidFill>
+                <a:latin typeface="Calibri"/>
+              </a:rPr>
+              <a:t>Recomendação: reforçar a validação obrigatória destes campos no preenchimento/atualização no Inovar, para melhorar a fiabilidade de futuras análises e do apoio à decisão.</a:t>
+            </a:r>
+          </a:p>
+        </p:txBody>
+      </p:sp>
+      <p:sp>
+        <p:nvSpPr>
+          <p:cNvPr id="6" name="TextBox 5"/>
+          <p:cNvSpPr txBox="1"/>
+          <p:nvPr/>
+        </p:nvSpPr>
+        <p:spPr>
+          <a:xfrm>
+            <a:off x="548640" y="6473952"/>
+            <a:ext cx="8229600" cy="320040"/>
+          </a:xfrm>
+          <a:prstGeom prst="rect">
+            <a:avLst/>
+          </a:prstGeom>
+          <a:noFill/>
+        </p:spPr>
+        <p:txBody>
+          <a:bodyPr wrap="square" anchor="t" lIns="0" rIns="0" tIns="0" bIns="0">
+            <a:spAutoFit/>
+          </a:bodyPr>
+          <a:lstStyle/>
+          <a:p>
+            <a:pPr algn="l">
+              <a:lnSpc>
+                <a:spcPct val="100000"/>
+              </a:lnSpc>
+            </a:pPr>
+            <a:r>
+              <a:rPr sz="1000" b="0" i="1">
+                <a:solidFill>
+                  <a:srgbClr val="52514E"/>
+                </a:solidFill>
+                <a:latin typeface="Calibri"/>
+              </a:rPr>
+              <a:t>% de valores 'N/A' por campo, sobre os 463 registos</a:t>
+            </a:r>
+          </a:p>
+        </p:txBody>
+      </p:sp>
+      <p:sp>
+        <p:nvSpPr>
+          <p:cNvPr id="7" name="TextBox 6"/>
+          <p:cNvSpPr txBox="1"/>
+          <p:nvPr/>
+        </p:nvSpPr>
+        <p:spPr>
+          <a:xfrm>
+            <a:off x="10241280" y="6473952"/>
+            <a:ext cx="1371600" cy="320040"/>
+          </a:xfrm>
+          <a:prstGeom prst="rect">
+            <a:avLst/>
+          </a:prstGeom>
+          <a:noFill/>
+        </p:spPr>
+        <p:txBody>
+          <a:bodyPr wrap="square" anchor="t" lIns="0" rIns="0" tIns="0" bIns="0">
+            <a:spAutoFit/>
+          </a:bodyPr>
+          <a:lstStyle/>
+          <a:p>
+            <a:pPr algn="r">
+              <a:lnSpc>
+                <a:spcPct val="100000"/>
+              </a:lnSpc>
+            </a:pPr>
+            <a:r>
+              <a:rPr sz="1000" b="0" i="1">
+                <a:solidFill>
+                  <a:srgbClr val="52514E"/>
+                </a:solidFill>
+                <a:latin typeface="Calibri"/>
+              </a:rPr>
+              <a:t>Escola Francisco de Arruda</a:t>
+            </a:r>
+          </a:p>
+        </p:txBody>
+      </p:sp>
+    </p:spTree>
+  </p:cSld>
+  <p:clrMapOvr>
+    <a:masterClrMapping/>
+  </p:clrMapOvr>
+</p:sld>
+</file>
+
+<file path=ppt/slides/slide12.xml><?xml version="1.0" encoding="utf-8"?>
+<p:sld xmlns:a="http://schemas.openxmlformats.org/drawingml/2006/main" xmlns:p="http://schemas.openxmlformats.org/presentationml/2006/main" xmlns:r="http://schemas.openxmlformats.org/officeDocument/2006/relationships">
+  <p:cSld>
+    <p:spTree>
+      <p:nvGrpSpPr>
+        <p:cNvPr id="1" name=""/>
+        <p:cNvGrpSpPr/>
+        <p:nvPr/>
+      </p:nvGrpSpPr>
+      <p:grpSpPr/>
+      <p:sp>
+        <p:nvSpPr>
+          <p:cNvPr id="2" name="Rectangle 1"/>
+          <p:cNvSpPr/>
+          <p:nvPr/>
+        </p:nvSpPr>
+        <p:spPr>
+          <a:xfrm>
+            <a:off x="0" y="0"/>
+            <a:ext cx="12191695" cy="6858000"/>
+          </a:xfrm>
+          <a:prstGeom prst="rect">
+            <a:avLst/>
+          </a:prstGeom>
+          <a:solidFill>
+            <a:srgbClr val="1C4F52"/>
+          </a:solidFill>
+          <a:ln>
+            <a:noFill/>
+          </a:ln>
+          <a:effectLst/>
+        </p:spPr>
+        <p:style>
+          <a:lnRef idx="1">
+            <a:schemeClr val="accent1"/>
+          </a:lnRef>
+          <a:fillRef idx="3">
+            <a:schemeClr val="accent1"/>
+          </a:fillRef>
+          <a:effectRef idx="2">
+            <a:schemeClr val="accent1"/>
+          </a:effectRef>
+          <a:fontRef idx="minor">
+            <a:schemeClr val="lt1"/>
+          </a:fontRef>
+        </p:style>
+        <p:txBody>
+          <a:bodyPr rtlCol="0" anchor="ctr"/>
+          <a:lstStyle/>
+          <a:p>
+            <a:pPr algn="ctr"/>
+          </a:p>
+        </p:txBody>
+      </p:sp>
+      <p:sp>
+        <p:nvSpPr>
+          <p:cNvPr id="3" name="TextBox 2"/>
+          <p:cNvSpPr txBox="1"/>
+          <p:nvPr/>
+        </p:nvSpPr>
+        <p:spPr>
+          <a:xfrm>
+            <a:off x="640080" y="502920"/>
+            <a:ext cx="10881360" cy="822960"/>
+          </a:xfrm>
+          <a:prstGeom prst="rect">
+            <a:avLst/>
+          </a:prstGeom>
+          <a:noFill/>
+        </p:spPr>
+        <p:txBody>
+          <a:bodyPr wrap="square" anchor="t" lIns="0" rIns="0" tIns="0" bIns="0">
+            <a:spAutoFit/>
+          </a:bodyPr>
+          <a:lstStyle/>
+          <a:p>
+            <a:pPr algn="l">
+              <a:lnSpc>
+                <a:spcPct val="100000"/>
+              </a:lnSpc>
+            </a:pPr>
+            <a:r>
+              <a:rPr sz="3200" b="1" i="0">
+                <a:solidFill>
+                  <a:srgbClr val="FFFFFF"/>
+                </a:solidFill>
+                <a:latin typeface="Calibri"/>
+              </a:rPr>
+              <a:t>Conclusões e recomendações</a:t>
+            </a:r>
+          </a:p>
+        </p:txBody>
+      </p:sp>
+      <p:sp>
+        <p:nvSpPr>
+          <p:cNvPr id="4" name="TextBox 3"/>
+          <p:cNvSpPr txBox="1"/>
+          <p:nvPr/>
+        </p:nvSpPr>
+        <p:spPr>
+          <a:xfrm>
+            <a:off x="822960" y="1737360"/>
+            <a:ext cx="10515600" cy="4389120"/>
+          </a:xfrm>
+          <a:prstGeom prst="rect">
+            <a:avLst/>
+          </a:prstGeom>
+          <a:noFill/>
+        </p:spPr>
+        <p:txBody>
+          <a:bodyPr wrap="square">
+            <a:spAutoFit/>
+          </a:bodyPr>
+          <a:lstStyle/>
+          <a:p>
+            <a:pPr>
+              <a:lnSpc>
+                <a:spcPct val="115000"/>
+              </a:lnSpc>
+              <a:spcAft>
+                <a:spcPts val="1600"/>
+              </a:spcAft>
+            </a:pPr>
+            <a:r>
+              <a:rPr sz="1600">
+                <a:solidFill>
+                  <a:srgbClr val="FFFFFF"/>
+                </a:solidFill>
+                <a:latin typeface="Calibri"/>
+              </a:rPr>
+              <a:t>•  A escola serve uma população claramente diversa — mais de 10 nacionalidades, ~34% de alunos estrangeiros.</a:t>
+            </a:r>
+          </a:p>
+          <a:p>
+            <a:pPr>
+              <a:lnSpc>
+                <a:spcPct val="115000"/>
+              </a:lnSpc>
+              <a:spcAft>
+                <a:spcPts val="1600"/>
+              </a:spcAft>
+            </a:pPr>
+            <a:r>
+              <a:rPr sz="1600">
+                <a:solidFill>
+                  <a:srgbClr val="FFFFFF"/>
+                </a:solidFill>
+                <a:latin typeface="Calibri"/>
+              </a:rPr>
+              <a:t>•  58% dos alunos que ficam na escola têm ASE — e a taxa é quase o dobro entre portugueses (68%) face a estrangeiros (39%): merece investigação se é barreira de acesso, não de necessidade real.</a:t>
+            </a:r>
+          </a:p>
+          <a:p>
+            <a:pPr>
+              <a:lnSpc>
+                <a:spcPct val="115000"/>
+              </a:lnSpc>
+              <a:spcAft>
+                <a:spcPts val="1600"/>
+              </a:spcAft>
+            </a:pPr>
+            <a:r>
+              <a:rPr sz="1600">
+                <a:solidFill>
+                  <a:srgbClr val="FFFFFF"/>
+                </a:solidFill>
+                <a:latin typeface="Calibri"/>
+              </a:rPr>
+              <a:t>•  O acesso a computador é o principal fator limitante da literacia digital — mais do que o acesso a internet.</a:t>
+            </a:r>
+          </a:p>
+          <a:p>
+            <a:pPr>
+              <a:lnSpc>
+                <a:spcPct val="115000"/>
+              </a:lnSpc>
+              <a:spcAft>
+                <a:spcPts val="1600"/>
+              </a:spcAft>
+            </a:pPr>
+            <a:r>
+              <a:rPr sz="1600">
+                <a:solidFill>
+                  <a:srgbClr val="FFFFFF"/>
+                </a:solidFill>
+                <a:latin typeface="Calibri"/>
+              </a:rPr>
+              <a:t>•  Teatro lidera as primeiras escolhas de atividade; a distribuição muda nas escolhas seguintes.</a:t>
+            </a:r>
+          </a:p>
+          <a:p>
+            <a:pPr>
+              <a:lnSpc>
+                <a:spcPct val="115000"/>
+              </a:lnSpc>
+              <a:spcAft>
+                <a:spcPts val="1600"/>
+              </a:spcAft>
+            </a:pPr>
+            <a:r>
+              <a:rPr sz="1600">
+                <a:solidFill>
+                  <a:srgbClr val="FFFFFF"/>
+                </a:solidFill>
+                <a:latin typeface="Calibri"/>
+              </a:rPr>
+              <a:t>•  ~19% dos alunos com estado de saúde conhecido têm alguma condição referida, sobretudo respiratória; ~9% têm restrição alimentar, sobretudo por motivo cultural/religioso (porco/vaca).</a:t>
+            </a:r>
+          </a:p>
+          <a:p>
+            <a:pPr>
+              <a:lnSpc>
+                <a:spcPct val="115000"/>
+              </a:lnSpc>
+              <a:spcAft>
+                <a:spcPts val="1600"/>
+              </a:spcAft>
+            </a:pPr>
+            <a:r>
+              <a:rPr sz="1600">
+                <a:solidFill>
+                  <a:srgbClr val="FFFFFF"/>
+                </a:solidFill>
+                <a:latin typeface="Calibri"/>
+              </a:rPr>
+              <a:t>•  Melhorar a validação de dados no Inovar (nacionalidade, data de nascimento) tornaria análises futuras mais fiáveis.</a:t>
+            </a:r>
+          </a:p>
+        </p:txBody>
+      </p:sp>
+    </p:spTree>
+  </p:cSld>
+  <p:clrMapOvr>
+    <a:masterClrMapping/>
+  </p:clrMapOvr>
+</p:sld>
+</file>
+
+<file path=ppt/slides/slide13.xml><?xml version="1.0" encoding="utf-8"?>
+<p:sld xmlns:a="http://schemas.openxmlformats.org/drawingml/2006/main" xmlns:p="http://schemas.openxmlformats.org/presentationml/2006/main" xmlns:r="http://schemas.openxmlformats.org/officeDocument/2006/relationships">
+  <p:cSld>
+    <p:spTree>
+      <p:nvGrpSpPr>
+        <p:cNvPr id="1" name=""/>
+        <p:cNvGrpSpPr/>
+        <p:nvPr/>
+      </p:nvGrpSpPr>
+      <p:grpSpPr/>
+      <p:sp>
+        <p:nvSpPr>
+          <p:cNvPr id="2" name="Rectangle 1"/>
+          <p:cNvSpPr/>
+          <p:nvPr/>
+        </p:nvSpPr>
+        <p:spPr>
+          <a:xfrm>
+            <a:off x="0" y="0"/>
+            <a:ext cx="12191695" cy="6858000"/>
+          </a:xfrm>
+          <a:prstGeom prst="rect">
+            <a:avLst/>
+          </a:prstGeom>
+          <a:solidFill>
             <a:srgbClr val="123537"/>
           </a:solidFill>
           <a:ln>
@@ -4692,20 +5590,20 @@
               </a:lnSpc>
             </a:pPr>
             <a:r>
-              <a:rPr sz="3000" b="1" i="0">
+              <a:rPr sz="2800" b="1" i="0">
                 <a:solidFill>
                   <a:srgbClr val="1C4F52"/>
                 </a:solidFill>
                 <a:latin typeface="Calibri"/>
               </a:rPr>
-              <a:t>Nacionalidade portuguesa vs. estrangeira</a:t>
+              <a:t>Fica na escola (atividades de tempos livres)</a:t>
             </a:r>
           </a:p>
         </p:txBody>
       </p:sp>
       <p:pic>
         <p:nvPicPr>
-          <p:cNvPr id="4" name="Picture 3" descr="chart_nationality_ratio.png"/>
+          <p:cNvPr id="4" name="Picture 3" descr="chart_fica_escola.png"/>
           <p:cNvPicPr>
             <a:picLocks noChangeAspect="1"/>
           </p:cNvPicPr>
@@ -4719,8 +5617,8 @@
         </p:blipFill>
         <p:spPr>
           <a:xfrm>
-            <a:off x="706684" y="1554480"/>
-            <a:ext cx="5627511" cy="4572000"/>
+            <a:off x="672191" y="1463040"/>
+            <a:ext cx="5696498" cy="4754880"/>
           </a:xfrm>
           <a:prstGeom prst="rect">
             <a:avLst/>
@@ -4735,8 +5633,8 @@
         </p:nvSpPr>
         <p:spPr>
           <a:xfrm>
-            <a:off x="6766560" y="2103120"/>
-            <a:ext cx="4754880" cy="914400"/>
+            <a:off x="6766560" y="1920240"/>
+            <a:ext cx="4754880" cy="4389120"/>
           </a:xfrm>
           <a:prstGeom prst="rect">
             <a:avLst/>
@@ -4751,17 +5649,81 @@
           <a:p>
             <a:pPr algn="l">
               <a:lnSpc>
-                <a:spcPct val="100000"/>
-              </a:lnSpc>
-            </a:pPr>
-            <a:r>
-              <a:rPr sz="4000" b="1" i="0">
-                <a:solidFill>
-                  <a:srgbClr val="C1592B"/>
-                </a:solidFill>
-                <a:latin typeface="Calibri"/>
-              </a:rPr>
-              <a:t>1 em cada 3</a:t>
+                <a:spcPct val="125000"/>
+              </a:lnSpc>
+            </a:pPr>
+            <a:r>
+              <a:rPr sz="1500" b="0" i="0">
+                <a:solidFill>
+                  <a:srgbClr val="1A1A1A"/>
+                </a:solidFill>
+                <a:latin typeface="Calibri"/>
+              </a:rPr>
+              <a:t>65% dos alunos ficam na escola para atividades de enriquecimento.</a:t>
+            </a:r>
+          </a:p>
+          <a:p>
+            <a:pPr algn="l">
+              <a:lnSpc>
+                <a:spcPct val="125000"/>
+              </a:lnSpc>
+            </a:pPr>
+            <a:r>
+              <a:rPr sz="1500" b="0" i="0">
+                <a:solidFill>
+                  <a:srgbClr val="1A1A1A"/>
+                </a:solidFill>
+                <a:latin typeface="Calibri"/>
+              </a:rPr>
+              <a:t/>
+            </a:r>
+          </a:p>
+          <a:p>
+            <a:pPr algn="l">
+              <a:lnSpc>
+                <a:spcPct val="125000"/>
+              </a:lnSpc>
+            </a:pPr>
+            <a:r>
+              <a:rPr sz="1500" b="0" i="0">
+                <a:solidFill>
+                  <a:srgbClr val="1A1A1A"/>
+                </a:solidFill>
+                <a:latin typeface="Calibri"/>
+              </a:rPr>
+              <a:t>Confirmámos que campos como ASE, RTP, PEI, acesso a PC/internet, oferta de escola e autorização de saída só são preenchidos para este grupo — em média, 90% desses campos ficam em branco para quem não fica.</a:t>
+            </a:r>
+          </a:p>
+          <a:p>
+            <a:pPr algn="l">
+              <a:lnSpc>
+                <a:spcPct val="125000"/>
+              </a:lnSpc>
+            </a:pPr>
+            <a:r>
+              <a:rPr sz="1500" b="0" i="0">
+                <a:solidFill>
+                  <a:srgbClr val="1A1A1A"/>
+                </a:solidFill>
+                <a:latin typeface="Calibri"/>
+              </a:rPr>
+              <a:t/>
+            </a:r>
+          </a:p>
+          <a:p>
+            <a:pPr algn="l">
+              <a:lnSpc>
+                <a:spcPct val="125000"/>
+              </a:lnSpc>
+            </a:pPr>
+            <a:r>
+              <a:rPr sz="1500" b="0" i="0">
+                <a:solidFill>
+                  <a:srgbClr val="1A1A1A"/>
+                </a:solidFill>
+                <a:latin typeface="Calibri"/>
+              </a:rPr>
+              <a:t>Por isso, todas as análises seguintes sobre estes temas são calculadas apenas sobre os alunos que ficam, para não subestimar as taxas reais.</a:t>
             </a:r>
           </a:p>
         </p:txBody>
@@ -4774,8 +5736,8 @@
         </p:nvSpPr>
         <p:spPr>
           <a:xfrm>
-            <a:off x="6766560" y="2834640"/>
-            <a:ext cx="4754880" cy="1280160"/>
+            <a:off x="548640" y="6473952"/>
+            <a:ext cx="8229600" cy="320040"/>
           </a:xfrm>
           <a:prstGeom prst="rect">
             <a:avLst/>
@@ -4790,17 +5752,17 @@
           <a:p>
             <a:pPr algn="l">
               <a:lnSpc>
-                <a:spcPct val="120000"/>
-              </a:lnSpc>
-            </a:pPr>
-            <a:r>
-              <a:rPr sz="1600" b="0" i="0">
-                <a:solidFill>
-                  <a:srgbClr val="1A1A1A"/>
-                </a:solidFill>
-                <a:latin typeface="Calibri"/>
-              </a:rPr>
-              <a:t>alunos com nacionalidade registada é de origem estrangeira — reflexo direto do papel do agrupamento na integração de uma comunidade diversa.</a:t>
+                <a:spcPct val="100000"/>
+              </a:lnSpc>
+            </a:pPr>
+            <a:r>
+              <a:rPr sz="1000" b="0" i="1">
+                <a:solidFill>
+                  <a:srgbClr val="52514E"/>
+                </a:solidFill>
+                <a:latin typeface="Calibri"/>
+              </a:rPr>
+              <a:t>301 de 463 alunos ficam na escola; 97 não ficam; 65 sem resposta</a:t>
             </a:r>
           </a:p>
         </p:txBody>
@@ -4808,84 +5770,6 @@
       <p:sp>
         <p:nvSpPr>
           <p:cNvPr id="7" name="TextBox 6"/>
-          <p:cNvSpPr txBox="1"/>
-          <p:nvPr/>
-        </p:nvSpPr>
-        <p:spPr>
-          <a:xfrm>
-            <a:off x="6766560" y="4846320"/>
-            <a:ext cx="4754880" cy="914400"/>
-          </a:xfrm>
-          <a:prstGeom prst="rect">
-            <a:avLst/>
-          </a:prstGeom>
-          <a:noFill/>
-        </p:spPr>
-        <p:txBody>
-          <a:bodyPr wrap="square" anchor="t" lIns="0" rIns="0" tIns="0" bIns="0">
-            <a:spAutoFit/>
-          </a:bodyPr>
-          <a:lstStyle/>
-          <a:p>
-            <a:pPr algn="l">
-              <a:lnSpc>
-                <a:spcPct val="100000"/>
-              </a:lnSpc>
-            </a:pPr>
-            <a:r>
-              <a:rPr sz="1200" b="0" i="1">
-                <a:solidFill>
-                  <a:srgbClr val="52514E"/>
-                </a:solidFill>
-                <a:latin typeface="Calibri"/>
-              </a:rPr>
-              <a:t>Nota: 64 alunos (13,8%) sem nacionalidade registada foram excluídos deste rácio para não distorcer o resultado.</a:t>
-            </a:r>
-          </a:p>
-        </p:txBody>
-      </p:sp>
-      <p:sp>
-        <p:nvSpPr>
-          <p:cNvPr id="8" name="TextBox 7"/>
-          <p:cNvSpPr txBox="1"/>
-          <p:nvPr/>
-        </p:nvSpPr>
-        <p:spPr>
-          <a:xfrm>
-            <a:off x="548640" y="6473952"/>
-            <a:ext cx="8229600" cy="320040"/>
-          </a:xfrm>
-          <a:prstGeom prst="rect">
-            <a:avLst/>
-          </a:prstGeom>
-          <a:noFill/>
-        </p:spPr>
-        <p:txBody>
-          <a:bodyPr wrap="square" anchor="t" lIns="0" rIns="0" tIns="0" bIns="0">
-            <a:spAutoFit/>
-          </a:bodyPr>
-          <a:lstStyle/>
-          <a:p>
-            <a:pPr algn="l">
-              <a:lnSpc>
-                <a:spcPct val="100000"/>
-              </a:lnSpc>
-            </a:pPr>
-            <a:r>
-              <a:rPr sz="1000" b="0" i="1">
-                <a:solidFill>
-                  <a:srgbClr val="52514E"/>
-                </a:solidFill>
-                <a:latin typeface="Calibri"/>
-              </a:rPr>
-              <a:t>Rácio calculado sobre alunos com nacionalidade conhecida (n=399)</a:t>
-            </a:r>
-          </a:p>
-        </p:txBody>
-      </p:sp>
-      <p:sp>
-        <p:nvSpPr>
-          <p:cNvPr id="9" name="TextBox 8"/>
           <p:cNvSpPr txBox="1"/>
           <p:nvPr/>
         </p:nvSpPr>
@@ -5018,14 +5902,14 @@
                 </a:solidFill>
                 <a:latin typeface="Calibri"/>
               </a:rPr>
-              <a:t>Nacionalidades representadas</a:t>
+              <a:t>Nacionalidade portuguesa vs. estrangeira</a:t>
             </a:r>
           </a:p>
         </p:txBody>
       </p:sp>
       <p:pic>
         <p:nvPicPr>
-          <p:cNvPr id="4" name="Picture 3" descr="chart_nationalities.png"/>
+          <p:cNvPr id="4" name="Picture 3" descr="chart_nationality_ratio.png"/>
           <p:cNvPicPr>
             <a:picLocks noChangeAspect="1"/>
           </p:cNvPicPr>
@@ -5039,8 +5923,8 @@
         </p:blipFill>
         <p:spPr>
           <a:xfrm>
-            <a:off x="1787174" y="1463040"/>
-            <a:ext cx="8587171" cy="4754880"/>
+            <a:off x="706684" y="1554480"/>
+            <a:ext cx="5627511" cy="4572000"/>
           </a:xfrm>
           <a:prstGeom prst="rect">
             <a:avLst/>
@@ -5055,8 +5939,8 @@
         </p:nvSpPr>
         <p:spPr>
           <a:xfrm>
-            <a:off x="548640" y="6473952"/>
-            <a:ext cx="8229600" cy="320040"/>
+            <a:off x="6766560" y="2103120"/>
+            <a:ext cx="4754880" cy="914400"/>
           </a:xfrm>
           <a:prstGeom prst="rect">
             <a:avLst/>
@@ -5075,20 +5959,137 @@
               </a:lnSpc>
             </a:pPr>
             <a:r>
+              <a:rPr sz="4000" b="1" i="0">
+                <a:solidFill>
+                  <a:srgbClr val="C1592B"/>
+                </a:solidFill>
+                <a:latin typeface="Calibri"/>
+              </a:rPr>
+              <a:t>1 em cada 3</a:t>
+            </a:r>
+          </a:p>
+        </p:txBody>
+      </p:sp>
+      <p:sp>
+        <p:nvSpPr>
+          <p:cNvPr id="6" name="TextBox 5"/>
+          <p:cNvSpPr txBox="1"/>
+          <p:nvPr/>
+        </p:nvSpPr>
+        <p:spPr>
+          <a:xfrm>
+            <a:off x="6766560" y="2834640"/>
+            <a:ext cx="4754880" cy="1280160"/>
+          </a:xfrm>
+          <a:prstGeom prst="rect">
+            <a:avLst/>
+          </a:prstGeom>
+          <a:noFill/>
+        </p:spPr>
+        <p:txBody>
+          <a:bodyPr wrap="square" anchor="t" lIns="0" rIns="0" tIns="0" bIns="0">
+            <a:spAutoFit/>
+          </a:bodyPr>
+          <a:lstStyle/>
+          <a:p>
+            <a:pPr algn="l">
+              <a:lnSpc>
+                <a:spcPct val="120000"/>
+              </a:lnSpc>
+            </a:pPr>
+            <a:r>
+              <a:rPr sz="1600" b="0" i="0">
+                <a:solidFill>
+                  <a:srgbClr val="1A1A1A"/>
+                </a:solidFill>
+                <a:latin typeface="Calibri"/>
+              </a:rPr>
+              <a:t>alunos com nacionalidade registada é de origem estrangeira — reflexo direto do papel do agrupamento na integração de uma comunidade diversa.</a:t>
+            </a:r>
+          </a:p>
+        </p:txBody>
+      </p:sp>
+      <p:sp>
+        <p:nvSpPr>
+          <p:cNvPr id="7" name="TextBox 6"/>
+          <p:cNvSpPr txBox="1"/>
+          <p:nvPr/>
+        </p:nvSpPr>
+        <p:spPr>
+          <a:xfrm>
+            <a:off x="6766560" y="4846320"/>
+            <a:ext cx="4754880" cy="914400"/>
+          </a:xfrm>
+          <a:prstGeom prst="rect">
+            <a:avLst/>
+          </a:prstGeom>
+          <a:noFill/>
+        </p:spPr>
+        <p:txBody>
+          <a:bodyPr wrap="square" anchor="t" lIns="0" rIns="0" tIns="0" bIns="0">
+            <a:spAutoFit/>
+          </a:bodyPr>
+          <a:lstStyle/>
+          <a:p>
+            <a:pPr algn="l">
+              <a:lnSpc>
+                <a:spcPct val="100000"/>
+              </a:lnSpc>
+            </a:pPr>
+            <a:r>
+              <a:rPr sz="1200" b="0" i="1">
+                <a:solidFill>
+                  <a:srgbClr val="52514E"/>
+                </a:solidFill>
+                <a:latin typeface="Calibri"/>
+              </a:rPr>
+              <a:t>Nota: 64 alunos (13,8%) sem nacionalidade registada foram excluídos deste rácio para não distorcer o resultado.</a:t>
+            </a:r>
+          </a:p>
+        </p:txBody>
+      </p:sp>
+      <p:sp>
+        <p:nvSpPr>
+          <p:cNvPr id="8" name="TextBox 7"/>
+          <p:cNvSpPr txBox="1"/>
+          <p:nvPr/>
+        </p:nvSpPr>
+        <p:spPr>
+          <a:xfrm>
+            <a:off x="548640" y="6473952"/>
+            <a:ext cx="8229600" cy="320040"/>
+          </a:xfrm>
+          <a:prstGeom prst="rect">
+            <a:avLst/>
+          </a:prstGeom>
+          <a:noFill/>
+        </p:spPr>
+        <p:txBody>
+          <a:bodyPr wrap="square" anchor="t" lIns="0" rIns="0" tIns="0" bIns="0">
+            <a:spAutoFit/>
+          </a:bodyPr>
+          <a:lstStyle/>
+          <a:p>
+            <a:pPr algn="l">
+              <a:lnSpc>
+                <a:spcPct val="100000"/>
+              </a:lnSpc>
+            </a:pPr>
+            <a:r>
               <a:rPr sz="1000" b="0" i="1">
                 <a:solidFill>
                   <a:srgbClr val="52514E"/>
                 </a:solidFill>
                 <a:latin typeface="Calibri"/>
               </a:rPr>
-              <a:t>'Outra' agrupa nacionalidades com menos de 3 alunos na escola</a:t>
-            </a:r>
-          </a:p>
-        </p:txBody>
-      </p:sp>
-      <p:sp>
-        <p:nvSpPr>
-          <p:cNvPr id="6" name="TextBox 5"/>
+              <a:t>Rácio calculado sobre alunos com nacionalidade conhecida (n=399)</a:t>
+            </a:r>
+          </a:p>
+        </p:txBody>
+      </p:sp>
+      <p:sp>
+        <p:nvSpPr>
+          <p:cNvPr id="9" name="TextBox 8"/>
           <p:cNvSpPr txBox="1"/>
           <p:nvPr/>
         </p:nvSpPr>
@@ -5215,20 +6216,20 @@
               </a:lnSpc>
             </a:pPr>
             <a:r>
-              <a:rPr sz="2800" b="1" i="0">
+              <a:rPr sz="3000" b="1" i="0">
                 <a:solidFill>
                   <a:srgbClr val="1C4F52"/>
                 </a:solidFill>
                 <a:latin typeface="Calibri"/>
               </a:rPr>
-              <a:t>Apoio socioeconómico (ASE), por ano de escolaridade</a:t>
+              <a:t>Nacionalidades representadas</a:t>
             </a:r>
           </a:p>
         </p:txBody>
       </p:sp>
       <p:pic>
         <p:nvPicPr>
-          <p:cNvPr id="4" name="Picture 3" descr="chart_ase_by_grade.png"/>
+          <p:cNvPr id="4" name="Picture 3" descr="chart_nationalities.png"/>
           <p:cNvPicPr>
             <a:picLocks noChangeAspect="1"/>
           </p:cNvPicPr>
@@ -5242,8 +6243,8 @@
         </p:blipFill>
         <p:spPr>
           <a:xfrm>
-            <a:off x="640080" y="2020613"/>
-            <a:ext cx="6949440" cy="3639733"/>
+            <a:off x="1787174" y="1463040"/>
+            <a:ext cx="8587171" cy="4754880"/>
           </a:xfrm>
           <a:prstGeom prst="rect">
             <a:avLst/>
@@ -5258,8 +6259,8 @@
         </p:nvSpPr>
         <p:spPr>
           <a:xfrm>
-            <a:off x="7863840" y="1920240"/>
-            <a:ext cx="3749039" cy="4114800"/>
+            <a:off x="548640" y="6473952"/>
+            <a:ext cx="8229600" cy="320040"/>
           </a:xfrm>
           <a:prstGeom prst="rect">
             <a:avLst/>
@@ -5274,49 +6275,17 @@
           <a:p>
             <a:pPr algn="l">
               <a:lnSpc>
-                <a:spcPct val="125000"/>
-              </a:lnSpc>
-            </a:pPr>
-            <a:r>
-              <a:rPr sz="1500" b="0" i="0">
-                <a:solidFill>
-                  <a:srgbClr val="1A1A1A"/>
-                </a:solidFill>
-                <a:latin typeface="Calibri"/>
-              </a:rPr>
-              <a:t>A Ação Social Escolar (ASE) é o principal indicador de vulnerabilidade socioeconómica disponível nestes dados.</a:t>
-            </a:r>
-          </a:p>
-          <a:p>
-            <a:pPr algn="l">
-              <a:lnSpc>
-                <a:spcPct val="125000"/>
-              </a:lnSpc>
-            </a:pPr>
-            <a:r>
-              <a:rPr sz="1500" b="0" i="0">
-                <a:solidFill>
-                  <a:srgbClr val="1A1A1A"/>
-                </a:solidFill>
-                <a:latin typeface="Calibri"/>
-              </a:rPr>
-              <a:t/>
-            </a:r>
-          </a:p>
-          <a:p>
-            <a:pPr algn="l">
-              <a:lnSpc>
-                <a:spcPct val="125000"/>
-              </a:lnSpc>
-            </a:pPr>
-            <a:r>
-              <a:rPr sz="1500" b="0" i="0">
-                <a:solidFill>
-                  <a:srgbClr val="1A1A1A"/>
-                </a:solidFill>
-                <a:latin typeface="Calibri"/>
-              </a:rPr>
-              <a:t>A taxa varia significativamente entre anos, e é claramente mais baixa entre alunos estrangeiros — um sinal a investigar: pode refletir menor candidatura ao ASE, não necessariamente menor necessidade.</a:t>
+                <a:spcPct val="100000"/>
+              </a:lnSpc>
+            </a:pPr>
+            <a:r>
+              <a:rPr sz="1000" b="0" i="1">
+                <a:solidFill>
+                  <a:srgbClr val="52514E"/>
+                </a:solidFill>
+                <a:latin typeface="Calibri"/>
+              </a:rPr>
+              <a:t>'Outra' agrupa nacionalidades com menos de 3 alunos na escola</a:t>
             </a:r>
           </a:p>
         </p:txBody>
@@ -5324,45 +6293,6 @@
       <p:sp>
         <p:nvSpPr>
           <p:cNvPr id="6" name="TextBox 5"/>
-          <p:cNvSpPr txBox="1"/>
-          <p:nvPr/>
-        </p:nvSpPr>
-        <p:spPr>
-          <a:xfrm>
-            <a:off x="548640" y="6473952"/>
-            <a:ext cx="8229600" cy="320040"/>
-          </a:xfrm>
-          <a:prstGeom prst="rect">
-            <a:avLst/>
-          </a:prstGeom>
-          <a:noFill/>
-        </p:spPr>
-        <p:txBody>
-          <a:bodyPr wrap="square" anchor="t" lIns="0" rIns="0" tIns="0" bIns="0">
-            <a:spAutoFit/>
-          </a:bodyPr>
-          <a:lstStyle/>
-          <a:p>
-            <a:pPr algn="l">
-              <a:lnSpc>
-                <a:spcPct val="100000"/>
-              </a:lnSpc>
-            </a:pPr>
-            <a:r>
-              <a:rPr sz="1000" b="0" i="1">
-                <a:solidFill>
-                  <a:srgbClr val="52514E"/>
-                </a:solidFill>
-                <a:latin typeface="Calibri"/>
-              </a:rPr>
-              <a:t>ASE = Ação Social Escolar</a:t>
-            </a:r>
-          </a:p>
-        </p:txBody>
-      </p:sp>
-      <p:sp>
-        <p:nvSpPr>
-          <p:cNvPr id="7" name="TextBox 6"/>
           <p:cNvSpPr txBox="1"/>
           <p:nvPr/>
         </p:nvSpPr>
@@ -5489,20 +6419,20 @@
               </a:lnSpc>
             </a:pPr>
             <a:r>
-              <a:rPr sz="3000" b="1" i="0">
+              <a:rPr sz="2800" b="1" i="0">
                 <a:solidFill>
                   <a:srgbClr val="1C4F52"/>
                 </a:solidFill>
                 <a:latin typeface="Calibri"/>
               </a:rPr>
-              <a:t>Acesso digital em casa</a:t>
+              <a:t>Apoio socioeconómico (ASE), por ano de escolaridade</a:t>
             </a:r>
           </a:p>
         </p:txBody>
       </p:sp>
       <p:pic>
         <p:nvPicPr>
-          <p:cNvPr id="4" name="Picture 3" descr="chart_digital_access.png"/>
+          <p:cNvPr id="4" name="Picture 3" descr="chart_ase_by_grade.png"/>
           <p:cNvPicPr>
             <a:picLocks noChangeAspect="1"/>
           </p:cNvPicPr>
@@ -5516,8 +6446,8 @@
         </p:blipFill>
         <p:spPr>
           <a:xfrm>
-            <a:off x="640080" y="1734920"/>
-            <a:ext cx="6949440" cy="4211120"/>
+            <a:off x="640080" y="2015898"/>
+            <a:ext cx="6949440" cy="3649163"/>
           </a:xfrm>
           <a:prstGeom prst="rect">
             <a:avLst/>
@@ -5533,7 +6463,7 @@
         <p:spPr>
           <a:xfrm>
             <a:off x="7863840" y="1920240"/>
-            <a:ext cx="3749039" cy="4114800"/>
+            <a:ext cx="3749039" cy="822960"/>
           </a:xfrm>
           <a:prstGeom prst="rect">
             <a:avLst/>
@@ -5548,49 +6478,17 @@
           <a:p>
             <a:pPr algn="l">
               <a:lnSpc>
-                <a:spcPct val="125000"/>
-              </a:lnSpc>
-            </a:pPr>
-            <a:r>
-              <a:rPr sz="1500" b="0" i="0">
-                <a:solidFill>
-                  <a:srgbClr val="1A1A1A"/>
-                </a:solidFill>
-                <a:latin typeface="Calibri"/>
-              </a:rPr>
-              <a:t>O acesso a internet em casa é consideravelmente mais alto do que o acesso a computador próprio.</a:t>
-            </a:r>
-          </a:p>
-          <a:p>
-            <a:pPr algn="l">
-              <a:lnSpc>
-                <a:spcPct val="125000"/>
-              </a:lnSpc>
-            </a:pPr>
-            <a:r>
-              <a:rPr sz="1500" b="0" i="0">
-                <a:solidFill>
-                  <a:srgbClr val="1A1A1A"/>
-                </a:solidFill>
-                <a:latin typeface="Calibri"/>
-              </a:rPr>
-              <a:t/>
-            </a:r>
-          </a:p>
-          <a:p>
-            <a:pPr algn="l">
-              <a:lnSpc>
-                <a:spcPct val="125000"/>
-              </a:lnSpc>
-            </a:pPr>
-            <a:r>
-              <a:rPr sz="1500" b="0" i="0">
-                <a:solidFill>
-                  <a:srgbClr val="1A1A1A"/>
-                </a:solidFill>
-                <a:latin typeface="Calibri"/>
-              </a:rPr>
-              <a:t>Relevante para qualquer estratégia de ensino ou trabalhos de casa que dependa de dispositivo próprio — o telemóvel é provavelmente a via de acesso à internet mais comum nestes casos.</a:t>
+                <a:spcPct val="100000"/>
+              </a:lnSpc>
+            </a:pPr>
+            <a:r>
+              <a:rPr sz="4000" b="1" i="0">
+                <a:solidFill>
+                  <a:srgbClr val="C1592B"/>
+                </a:solidFill>
+                <a:latin typeface="Calibri"/>
+              </a:rPr>
+              <a:t>58%</a:t>
             </a:r>
           </a:p>
         </p:txBody>
@@ -5603,8 +6501,8 @@
         </p:nvSpPr>
         <p:spPr>
           <a:xfrm>
-            <a:off x="548640" y="6473952"/>
-            <a:ext cx="8229600" cy="320040"/>
+            <a:off x="7863840" y="2606040"/>
+            <a:ext cx="3749039" cy="822960"/>
           </a:xfrm>
           <a:prstGeom prst="rect">
             <a:avLst/>
@@ -5619,6 +6517,116 @@
           <a:p>
             <a:pPr algn="l">
               <a:lnSpc>
+                <a:spcPct val="120000"/>
+              </a:lnSpc>
+            </a:pPr>
+            <a:r>
+              <a:rPr sz="1400" b="0" i="0">
+                <a:solidFill>
+                  <a:srgbClr val="1A1A1A"/>
+                </a:solidFill>
+                <a:latin typeface="Calibri"/>
+              </a:rPr>
+              <a:t>dos alunos que ficam na escola (175 de 301) têm ASE.</a:t>
+            </a:r>
+          </a:p>
+        </p:txBody>
+      </p:sp>
+      <p:sp>
+        <p:nvSpPr>
+          <p:cNvPr id="7" name="TextBox 6"/>
+          <p:cNvSpPr txBox="1"/>
+          <p:nvPr/>
+        </p:nvSpPr>
+        <p:spPr>
+          <a:xfrm>
+            <a:off x="7863840" y="3566160"/>
+            <a:ext cx="3749039" cy="2468880"/>
+          </a:xfrm>
+          <a:prstGeom prst="rect">
+            <a:avLst/>
+          </a:prstGeom>
+          <a:noFill/>
+        </p:spPr>
+        <p:txBody>
+          <a:bodyPr wrap="square" anchor="t" lIns="0" rIns="0" tIns="0" bIns="0">
+            <a:spAutoFit/>
+          </a:bodyPr>
+          <a:lstStyle/>
+          <a:p>
+            <a:pPr algn="l">
+              <a:lnSpc>
+                <a:spcPct val="120000"/>
+              </a:lnSpc>
+            </a:pPr>
+            <a:r>
+              <a:rPr sz="1400" b="0" i="0">
+                <a:solidFill>
+                  <a:srgbClr val="1A1A1A"/>
+                </a:solidFill>
+                <a:latin typeface="Calibri"/>
+              </a:rPr>
+              <a:t>A Ação Social Escolar (ASE) é o principal indicador de vulnerabilidade socioeconómica disponível nestes dados — central à missão TEIP.</a:t>
+            </a:r>
+          </a:p>
+          <a:p>
+            <a:pPr algn="l">
+              <a:lnSpc>
+                <a:spcPct val="120000"/>
+              </a:lnSpc>
+            </a:pPr>
+            <a:r>
+              <a:rPr sz="1400" b="0" i="0">
+                <a:solidFill>
+                  <a:srgbClr val="1A1A1A"/>
+                </a:solidFill>
+                <a:latin typeface="Calibri"/>
+              </a:rPr>
+              <a:t/>
+            </a:r>
+          </a:p>
+          <a:p>
+            <a:pPr algn="l">
+              <a:lnSpc>
+                <a:spcPct val="120000"/>
+              </a:lnSpc>
+            </a:pPr>
+            <a:r>
+              <a:rPr sz="1400" b="0" i="0">
+                <a:solidFill>
+                  <a:srgbClr val="1A1A1A"/>
+                </a:solidFill>
+                <a:latin typeface="Calibri"/>
+              </a:rPr>
+              <a:t>A taxa é claramente mais baixa entre alunos estrangeiros (39% vs. 68% entre os portugueses) — um sinal a investigar: pode refletir menor candidatura ao ASE, não necessariamente menor necessidade.</a:t>
+            </a:r>
+          </a:p>
+        </p:txBody>
+      </p:sp>
+      <p:sp>
+        <p:nvSpPr>
+          <p:cNvPr id="8" name="TextBox 7"/>
+          <p:cNvSpPr txBox="1"/>
+          <p:nvPr/>
+        </p:nvSpPr>
+        <p:spPr>
+          <a:xfrm>
+            <a:off x="548640" y="6473952"/>
+            <a:ext cx="8229600" cy="320040"/>
+          </a:xfrm>
+          <a:prstGeom prst="rect">
+            <a:avLst/>
+          </a:prstGeom>
+          <a:noFill/>
+        </p:spPr>
+        <p:txBody>
+          <a:bodyPr wrap="square" anchor="t" lIns="0" rIns="0" tIns="0" bIns="0">
+            <a:spAutoFit/>
+          </a:bodyPr>
+          <a:lstStyle/>
+          <a:p>
+            <a:pPr algn="l">
+              <a:lnSpc>
                 <a:spcPct val="100000"/>
               </a:lnSpc>
             </a:pPr>
@@ -5629,14 +6637,14 @@
                 </a:solidFill>
                 <a:latin typeface="Calibri"/>
               </a:rPr>
-              <a:t>Tem PC / Tem Internet — autodeclarado pelo encarregado de educação</a:t>
-            </a:r>
-          </a:p>
-        </p:txBody>
-      </p:sp>
-      <p:sp>
-        <p:nvSpPr>
-          <p:cNvPr id="7" name="TextBox 6"/>
+              <a:t>ASE = Ação Social Escolar; calculado sobre alunos que ficam na escola</a:t>
+            </a:r>
+          </a:p>
+        </p:txBody>
+      </p:sp>
+      <p:sp>
+        <p:nvSpPr>
+          <p:cNvPr id="9" name="TextBox 8"/>
           <p:cNvSpPr txBox="1"/>
           <p:nvPr/>
         </p:nvSpPr>
@@ -5763,20 +6771,20 @@
               </a:lnSpc>
             </a:pPr>
             <a:r>
-              <a:rPr sz="2600" b="1" i="0">
+              <a:rPr sz="3000" b="1" i="0">
                 <a:solidFill>
                   <a:srgbClr val="1C4F52"/>
                 </a:solidFill>
                 <a:latin typeface="Calibri"/>
               </a:rPr>
-              <a:t>Qualidade dos dados — uma oportunidade de melhoria</a:t>
+              <a:t>Acesso digital em casa</a:t>
             </a:r>
           </a:p>
         </p:txBody>
       </p:sp>
       <p:pic>
         <p:nvPicPr>
-          <p:cNvPr id="4" name="Picture 3" descr="chart_missing_data.png"/>
+          <p:cNvPr id="4" name="Picture 3" descr="chart_digital_access.png"/>
           <p:cNvPicPr>
             <a:picLocks noChangeAspect="1"/>
           </p:cNvPicPr>
@@ -5790,8 +6798,8 @@
         </p:blipFill>
         <p:spPr>
           <a:xfrm>
-            <a:off x="640080" y="1556958"/>
-            <a:ext cx="6949440" cy="4567043"/>
+            <a:off x="640080" y="1729465"/>
+            <a:ext cx="6949440" cy="4222030"/>
           </a:xfrm>
           <a:prstGeom prst="rect">
             <a:avLst/>
@@ -5807,7 +6815,7 @@
         <p:spPr>
           <a:xfrm>
             <a:off x="7863840" y="1920240"/>
-            <a:ext cx="3749039" cy="4297680"/>
+            <a:ext cx="3749039" cy="4114800"/>
           </a:xfrm>
           <a:prstGeom prst="rect">
             <a:avLst/>
@@ -5832,7 +6840,7 @@
                 </a:solidFill>
                 <a:latin typeface="Calibri"/>
               </a:rPr>
-              <a:t>Vários campos têm 30%+ de valores em falta — incluindo nacionalidade e data de nascimento em alguns casos.</a:t>
+              <a:t>O acesso a internet em casa é consideravelmente mais alto do que o acesso a computador próprio.</a:t>
             </a:r>
           </a:p>
           <a:p>
@@ -5864,7 +6872,7 @@
                 </a:solidFill>
                 <a:latin typeface="Calibri"/>
               </a:rPr>
-              <a:t>Recomendação: reforçar a validação obrigatória destes campos no preenchimento/atualização no Inovar, para melhorar a fiabilidade de futuras análises e do apoio à decisão.</a:t>
+              <a:t>Relevante para qualquer estratégia de ensino ou trabalhos de casa que dependa de dispositivo próprio — o telemóvel é provavelmente a via de acesso à internet mais comum nestes casos.</a:t>
             </a:r>
           </a:p>
         </p:txBody>
@@ -5903,7 +6911,7 @@
                 </a:solidFill>
                 <a:latin typeface="Calibri"/>
               </a:rPr>
-              <a:t>% de valores 'N/A' por campo, sobre os 463 registos</a:t>
+              <a:t>Tem PC / Tem Internet — autodeclarado pelo encarregado de educação</a:t>
             </a:r>
           </a:p>
         </p:txBody>
@@ -5980,7 +6988,7 @@
             <a:avLst/>
           </a:prstGeom>
           <a:solidFill>
-            <a:srgbClr val="1C4F52"/>
+            <a:srgbClr val="FFFFFF"/>
           </a:solidFill>
           <a:ln>
             <a:noFill/>
@@ -6037,27 +7045,51 @@
               </a:lnSpc>
             </a:pPr>
             <a:r>
-              <a:rPr sz="3200" b="1" i="0">
-                <a:solidFill>
-                  <a:srgbClr val="FFFFFF"/>
-                </a:solidFill>
-                <a:latin typeface="Calibri"/>
-              </a:rPr>
-              <a:t>Conclusões e recomendações</a:t>
-            </a:r>
-          </a:p>
-        </p:txBody>
-      </p:sp>
-      <p:sp>
-        <p:nvSpPr>
-          <p:cNvPr id="4" name="TextBox 3"/>
+              <a:rPr sz="2800" b="1" i="0">
+                <a:solidFill>
+                  <a:srgbClr val="1C4F52"/>
+                </a:solidFill>
+                <a:latin typeface="Calibri"/>
+              </a:rPr>
+              <a:t>Oferta de escola: 1ª escolha de atividade</a:t>
+            </a:r>
+          </a:p>
+        </p:txBody>
+      </p:sp>
+      <p:pic>
+        <p:nvPicPr>
+          <p:cNvPr id="4" name="Picture 3" descr="chart_oferta_escola.png"/>
+          <p:cNvPicPr>
+            <a:picLocks noChangeAspect="1"/>
+          </p:cNvPicPr>
+          <p:nvPr/>
+        </p:nvPicPr>
+        <p:blipFill>
+          <a:blip r:embed="rId2"/>
+          <a:stretch>
+            <a:fillRect/>
+          </a:stretch>
+        </p:blipFill>
+        <p:spPr>
+          <a:xfrm>
+            <a:off x="640080" y="1623096"/>
+            <a:ext cx="6949440" cy="4434768"/>
+          </a:xfrm>
+          <a:prstGeom prst="rect">
+            <a:avLst/>
+          </a:prstGeom>
+        </p:spPr>
+      </p:pic>
+      <p:sp>
+        <p:nvSpPr>
+          <p:cNvPr id="5" name="TextBox 4"/>
           <p:cNvSpPr txBox="1"/>
           <p:nvPr/>
         </p:nvSpPr>
         <p:spPr>
           <a:xfrm>
-            <a:off x="822960" y="1737360"/>
-            <a:ext cx="10515600" cy="4389120"/>
+            <a:off x="7863840" y="1920240"/>
+            <a:ext cx="3749039" cy="4114800"/>
           </a:xfrm>
           <a:prstGeom prst="rect">
             <a:avLst/>
@@ -6065,84 +7097,134 @@
           <a:noFill/>
         </p:spPr>
         <p:txBody>
-          <a:bodyPr wrap="square">
+          <a:bodyPr wrap="square" anchor="t" lIns="0" rIns="0" tIns="0" bIns="0">
             <a:spAutoFit/>
           </a:bodyPr>
           <a:lstStyle/>
           <a:p>
-            <a:pPr>
-              <a:lnSpc>
-                <a:spcPct val="115000"/>
-              </a:lnSpc>
-              <a:spcAft>
-                <a:spcPts val="2200"/>
-              </a:spcAft>
-            </a:pPr>
-            <a:r>
-              <a:rPr sz="1900">
-                <a:solidFill>
-                  <a:srgbClr val="FFFFFF"/>
-                </a:solidFill>
-                <a:latin typeface="Calibri"/>
-              </a:rPr>
-              <a:t>•  A escola serve uma população claramente diversa — mais de 10 nacionalidades, ~34% de alunos estrangeiros.</a:t>
-            </a:r>
-          </a:p>
-          <a:p>
-            <a:pPr>
-              <a:lnSpc>
-                <a:spcPct val="115000"/>
-              </a:lnSpc>
-              <a:spcAft>
-                <a:spcPts val="2200"/>
-              </a:spcAft>
-            </a:pPr>
-            <a:r>
-              <a:rPr sz="1900">
-                <a:solidFill>
-                  <a:srgbClr val="FFFFFF"/>
-                </a:solidFill>
-                <a:latin typeface="Calibri"/>
-              </a:rPr>
-              <a:t>•  A taxa de ASE mais baixa entre alunos estrangeiros merece investigação: pode indicar uma barreira de acesso/candidatura, não de necessidade real.</a:t>
-            </a:r>
-          </a:p>
-          <a:p>
-            <a:pPr>
-              <a:lnSpc>
-                <a:spcPct val="115000"/>
-              </a:lnSpc>
-              <a:spcAft>
-                <a:spcPts val="2200"/>
-              </a:spcAft>
-            </a:pPr>
-            <a:r>
-              <a:rPr sz="1900">
-                <a:solidFill>
-                  <a:srgbClr val="FFFFFF"/>
-                </a:solidFill>
-                <a:latin typeface="Calibri"/>
-              </a:rPr>
-              <a:t>•  O acesso a computador é o principal fator limitante da literacia digital — mais do que o acesso a internet.</a:t>
-            </a:r>
-          </a:p>
-          <a:p>
-            <a:pPr>
-              <a:lnSpc>
-                <a:spcPct val="115000"/>
-              </a:lnSpc>
-              <a:spcAft>
-                <a:spcPts val="2200"/>
-              </a:spcAft>
-            </a:pPr>
-            <a:r>
-              <a:rPr sz="1900">
-                <a:solidFill>
-                  <a:srgbClr val="FFFFFF"/>
-                </a:solidFill>
-                <a:latin typeface="Calibri"/>
-              </a:rPr>
-              <a:t>•  Melhorar a validação de dados no Inovar (nacionalidade, data de nascimento) tornaria análises futuras mais fiáveis.</a:t>
+            <a:pPr algn="l">
+              <a:lnSpc>
+                <a:spcPct val="125000"/>
+              </a:lnSpc>
+            </a:pPr>
+            <a:r>
+              <a:rPr sz="1500" b="0" i="0">
+                <a:solidFill>
+                  <a:srgbClr val="1A1A1A"/>
+                </a:solidFill>
+                <a:latin typeface="Calibri"/>
+              </a:rPr>
+              <a:t>Teatro é a atividade mais escolhida em 1ª opção, seguida de Música e Cenografia.</a:t>
+            </a:r>
+          </a:p>
+          <a:p>
+            <a:pPr algn="l">
+              <a:lnSpc>
+                <a:spcPct val="125000"/>
+              </a:lnSpc>
+            </a:pPr>
+            <a:r>
+              <a:rPr sz="1500" b="0" i="0">
+                <a:solidFill>
+                  <a:srgbClr val="1A1A1A"/>
+                </a:solidFill>
+                <a:latin typeface="Calibri"/>
+              </a:rPr>
+              <a:t/>
+            </a:r>
+          </a:p>
+          <a:p>
+            <a:pPr algn="l">
+              <a:lnSpc>
+                <a:spcPct val="125000"/>
+              </a:lnSpc>
+            </a:pPr>
+            <a:r>
+              <a:rPr sz="1500" b="0" i="0">
+                <a:solidFill>
+                  <a:srgbClr val="1A1A1A"/>
+                </a:solidFill>
+                <a:latin typeface="Calibri"/>
+              </a:rPr>
+              <a:t>Nas 2ª e 3ª escolhas a ordem muda (Cenografia passa a liderar) — indício de que os alunos distribuem as suas 3 escolhas pelas atividades disponíveis, em vez de repetir a mesma preferência.</a:t>
+            </a:r>
+          </a:p>
+        </p:txBody>
+      </p:sp>
+      <p:sp>
+        <p:nvSpPr>
+          <p:cNvPr id="6" name="TextBox 5"/>
+          <p:cNvSpPr txBox="1"/>
+          <p:nvPr/>
+        </p:nvSpPr>
+        <p:spPr>
+          <a:xfrm>
+            <a:off x="548640" y="6473952"/>
+            <a:ext cx="8229600" cy="320040"/>
+          </a:xfrm>
+          <a:prstGeom prst="rect">
+            <a:avLst/>
+          </a:prstGeom>
+          <a:noFill/>
+        </p:spPr>
+        <p:txBody>
+          <a:bodyPr wrap="square" anchor="t" lIns="0" rIns="0" tIns="0" bIns="0">
+            <a:spAutoFit/>
+          </a:bodyPr>
+          <a:lstStyle/>
+          <a:p>
+            <a:pPr algn="l">
+              <a:lnSpc>
+                <a:spcPct val="100000"/>
+              </a:lnSpc>
+            </a:pPr>
+            <a:r>
+              <a:rPr sz="1000" b="0" i="1">
+                <a:solidFill>
+                  <a:srgbClr val="52514E"/>
+                </a:solidFill>
+                <a:latin typeface="Calibri"/>
+              </a:rPr>
+              <a:t>Calculado sobre alunos que ficam na escola (n=301)</a:t>
+            </a:r>
+          </a:p>
+        </p:txBody>
+      </p:sp>
+      <p:sp>
+        <p:nvSpPr>
+          <p:cNvPr id="7" name="TextBox 6"/>
+          <p:cNvSpPr txBox="1"/>
+          <p:nvPr/>
+        </p:nvSpPr>
+        <p:spPr>
+          <a:xfrm>
+            <a:off x="10241280" y="6473952"/>
+            <a:ext cx="1371600" cy="320040"/>
+          </a:xfrm>
+          <a:prstGeom prst="rect">
+            <a:avLst/>
+          </a:prstGeom>
+          <a:noFill/>
+        </p:spPr>
+        <p:txBody>
+          <a:bodyPr wrap="square" anchor="t" lIns="0" rIns="0" tIns="0" bIns="0">
+            <a:spAutoFit/>
+          </a:bodyPr>
+          <a:lstStyle/>
+          <a:p>
+            <a:pPr algn="r">
+              <a:lnSpc>
+                <a:spcPct val="100000"/>
+              </a:lnSpc>
+            </a:pPr>
+            <a:r>
+              <a:rPr sz="1000" b="0" i="1">
+                <a:solidFill>
+                  <a:srgbClr val="52514E"/>
+                </a:solidFill>
+                <a:latin typeface="Calibri"/>
+              </a:rPr>
+              <a:t>Escola Francisco de Arruda</a:t>
             </a:r>
           </a:p>
         </p:txBody>

</xml_diff>